<commit_message>
Add main-test results to the slides and correct the sign-off claim
Co-Authored-By: Claude Sonnet 5.5 <noreply@anthropic.com>
</commit_message>
<xml_diff>
--- a/docs/project_slides.pptx
+++ b/docs/project_slides.pptx
@@ -128,7 +128,7 @@
                 </a:solidFill>
                 <a:latin typeface="Calibri"/>
               </a:rPr>
-              <a:t>Listed-spread volume by week, median of 8 recent rolls (%)</a:t>
+              <a:t>Mean absolute net spread change, 57 held-out rolls (ticks)</a:t>
             </a:r>
           </a:p>
         </c:rich>
@@ -139,7 +139,7 @@
     <c:autoTitleDeleted val="0"/>
     <c:plotArea>
       <c:barChart>
-        <c:barDir val="bar"/>
+        <c:barDir val="col"/>
         <c:grouping val="clustered"/>
         <c:ser>
           <c:idx val="0"/>
@@ -150,7 +150,7 @@
               <c:strCache>
                 <c:ptCount val="1"/>
                 <c:pt idx="0">
-                  <c:v>Share of listed-spread volume (%)</c:v>
+                  <c:v>Mean absolute net spread change (ticks)</c:v>
                 </c:pt>
               </c:strCache>
             </c:strRef>
@@ -159,20 +159,12 @@
             <c:idx val="0"/>
             <c:spPr>
               <a:solidFill>
-                <a:srgbClr val="9AA7C7"/>
+                <a:srgbClr val="3B5BA9"/>
               </a:solidFill>
             </c:spPr>
           </c:dPt>
           <c:dPt>
             <c:idx val="1"/>
-            <c:spPr>
-              <a:solidFill>
-                <a:srgbClr val="3B5BA9"/>
-              </a:solidFill>
-            </c:spPr>
-          </c:dPt>
-          <c:dPt>
-            <c:idx val="2"/>
             <c:spPr>
               <a:solidFill>
                 <a:srgbClr val="E3A71B"/>
@@ -181,16 +173,13 @@
           </c:dPt>
           <c:cat>
             <c:strRef>
-              <c:f>Sheet1!$A$2:$A$4</c:f>
+              <c:f>Sheet1!$A$2:$A$3</c:f>
               <c:strCache>
-                <c:ptCount val="3"/>
+                <c:ptCount val="2"/>
                 <c:pt idx="0">
-                  <c:v>Week before the roll week</c:v>
+                  <c:v>Roll week</c:v>
                 </c:pt>
                 <c:pt idx="1">
-                  <c:v>Roll week</c:v>
-                </c:pt>
-                <c:pt idx="2">
                   <c:v>Control week</c:v>
                 </c:pt>
               </c:strCache>
@@ -198,31 +187,28 @@
           </c:cat>
           <c:val>
             <c:numRef>
-              <c:f>Sheet1!$B$2:$B$4</c:f>
+              <c:f>Sheet1!$B$2:$B$3</c:f>
               <c:numCache>
                 <c:formatCode>General</c:formatCode>
-                <c:ptCount val="3"/>
+                <c:ptCount val="2"/>
                 <c:pt idx="0">
-                  <c:v>12</c:v>
+                  <c:v>3.22</c:v>
                 </c:pt>
                 <c:pt idx="1">
-                  <c:v>83</c:v>
-                </c:pt>
-                <c:pt idx="2">
-                  <c:v>1</c:v>
+                  <c:v>2.7</c:v>
                 </c:pt>
               </c:numCache>
             </c:numRef>
           </c:val>
         </c:ser>
         <c:dLbls>
-          <c:numFmt formatCode="0" sourceLinked="0"/>
+          <c:numFmt formatCode="0.00" sourceLinked="0"/>
           <c:txPr>
             <a:bodyPr/>
             <a:lstStyle/>
             <a:p>
               <a:pPr>
-                <a:defRPr sz="1200">
+                <a:defRPr sz="1400">
                   <a:solidFill>
                     <a:srgbClr val="1B2336"/>
                   </a:solidFill>
@@ -240,17 +226,17 @@
           <c:showBubbleSize val="0"/>
           <c:showLeaderLines val="1"/>
         </c:dLbls>
-        <c:gapWidth val="45"/>
+        <c:gapWidth val="60"/>
         <c:axId val="-2068027336"/>
         <c:axId val="-2113994440"/>
       </c:barChart>
       <c:catAx>
         <c:axId val="-2068027336"/>
         <c:scaling>
-          <c:orientation val="maxMin"/>
+          <c:orientation val="minMax"/>
         </c:scaling>
         <c:delete val="0"/>
-        <c:axPos val="l"/>
+        <c:axPos val="b"/>
         <c:majorTickMark val="out"/>
         <c:minorTickMark val="none"/>
         <c:tickLblPos val="nextTo"/>
@@ -266,7 +252,7 @@
           <a:lstStyle/>
           <a:p>
             <a:pPr>
-              <a:defRPr sz="1200">
+              <a:defRPr sz="1400">
                 <a:solidFill>
                   <a:srgbClr val="1B2336"/>
                 </a:solidFill>
@@ -285,11 +271,11 @@
       <c:valAx>
         <c:axId val="-2113994440"/>
         <c:scaling>
-          <c:max val="100.0"/>
+          <c:max val="4.0"/>
           <c:min val="0.0"/>
         </c:scaling>
         <c:delete/>
-        <c:axPos val="b"/>
+        <c:axPos val="l"/>
         <c:majorTickMark val="out"/>
         <c:minorTickMark val="none"/>
         <c:tickLblPos val="nextTo"/>
@@ -780,7 +766,7 @@
           <a:lstStyle/>
           <a:p>
             <a:r>
-              <a:t>The spread is the deferred contract's price minus the front contract's, measured in ticks at 10:00 Chicago time. The roll window is the last full Monday to Friday week before the front contract expires. The control window is the same pattern four weeks earlier for the same pair. For each roll we compare the absolute net move in the roll week with the absolute net move in the control week. The recent eight rolls are where the idea came from, so they cannot also be the test; the main test uses the 57 earlier rolls. The plan was written and signed off by all four of us before the main test is run.</a:t>
+              <a:t>The spread is the deferred contract's price minus the front contract's, measured in ticks at 10:00 Chicago time. The roll window is the last full Monday to Friday week before the front contract expires; the listed calendar spread trades 80 to 87 percent of its volume in that week in the eight recent rolls. The control window is the same pattern four weeks earlier for the same pair. For each roll we compare the absolute net move in the roll week with the absolute net move in the control week. The recent eight rolls are where the idea came from, so they cannot also be the test; the main test uses the 57 earlier rolls.</a:t>
             </a:r>
           </a:p>
         </p:txBody>
@@ -850,7 +836,7 @@
           <a:lstStyle/>
           <a:p>
             <a:r>
-              <a:t>Everything is a Python package with tests, built through pull requests that every member reviews. The data step downloads named contracts from Databento and caches them locally. The roll calendar uses the formula 'two business days before the third Wednesday' and we checked it against Databento's own definitions: 64 of 65 match. The one miss, 6EM3 in June 2023, expired a business day early because of Juneteenth, a CME holiday; that fix is in review. Statuses are as of late October.</a:t>
+              <a:t>Everything is a Python package with tests, built through pull requests that every member reviews. The data step downloads named contracts from Databento and caches them locally. The roll calendar uses the formula 'two business days before the third Wednesday' and we checked it against Databento's own definitions: 64 of 65 match. The one miss, 6EM3 in June 2023, expired a business day early because of Juneteenth, a CME holiday; the fix is in review along with the statistics and the main-test runner. Statuses are as of October 26.</a:t>
             </a:r>
           </a:p>
         </p:txBody>
@@ -920,7 +906,7 @@
           <a:lstStyle/>
           <a:p>
             <a:r>
-              <a:t>These are descriptive checks on the eight recent rolls, using volume and quote quality only; we have not looked at spread changes in the main sample. First, the listed calendar spread trades almost entirely in the roll week, which supports our window rule. Second, outright volume only crosses over on the Friday, about two days after spread trading peaks on Wednesday, so outright volume alone understates when rolling happens. Third, a liquidity check across all 65 rolls found the control week is usable but noisier: the deferred contract trades about 1 to 2 percent of its roll-week volume and its quotes are roughly twice as wide.</a:t>
+              <a:t>This is the main test on the 57 held-out rolls from September 2010 to September 2024. Roll weeks move a little more than control weeks, 3.2 ticks against 2.7 on average, but the average difference of half a tick is well inside the noise: the 95 percent interval runs from minus 1 to plus 2.2 ticks, and both the sign test and the Wilcoxon test are far from significant. The spread rose in 24 of the 50 roll weeks with a nonzero move, so there is no consistent direction either. The planned sensitivity checks, which drop wide quotes, drop weeks with Fed or ECB decisions, and adjust for carry, all agree. One added check, a control week three weeks out instead of four, gives a block-bootstrap interval that just excludes zero; it was not in the plan and comes from three large roll weeks. Because H1 and H2 do not hold we do not compute H3, the dollar cost. Numbers are from the main-test pull request, which is still in review.</a:t>
             </a:r>
           </a:p>
         </p:txBody>
@@ -990,7 +976,7 @@
           <a:lstStyle/>
           <a:p>
             <a:r>
-              <a:t>We fixed the analysis before running the main test, and every member signed off. That includes the statistics, the two bootstrap versions, and how we handle holidays and wide quotes. Be upfront about two limits. First, the control-week deferred contract is thinly quoted, which makes control moves look bigger and biases the magnitude test toward finding nothing, so a null result is weak evidence. Second, calendar spreads mostly reflect the interest-rate gap, so we compare with observed rates, and we cannot say who pays or that rolling caused a move. Remaining work: build the per-roll results table, run the main test on the 57 held-out rolls, robustness checks and the final report.</a:t>
+              <a:t>Be upfront about what the result means. We found no evidence of a roll-week effect, but the test is weaker than a flat no. The control week is further from expiry, where the deferred contract is quoted about twice as wide, which makes control moves look bigger and pushes the test toward finding nothing. In simulation a roll-week move 1.5 times the control's is detected only about 29 to 43 percent of the time with 57 rolls. Calendar spreads also mostly reflect the interest-rate gap, so we cannot say who pays or that rolling caused a move. Finally, we ran the main test on October 25 before the last team member's sign-off and before tagging the plan; that is recorded in the plan's deviation log.</a:t>
             </a:r>
           </a:p>
         </p:txBody>
@@ -4491,7 +4477,7 @@
         <p:spPr>
           <a:xfrm>
             <a:off x="548640" y="1325880"/>
-            <a:ext cx="3840480" cy="3017520"/>
+            <a:ext cx="3840480" cy="3108960"/>
           </a:xfrm>
           <a:prstGeom prst="rect">
             <a:avLst/>
@@ -4552,7 +4538,7 @@
                 </a:solidFill>
                 <a:latin typeface="Calibri"/>
               </a:rPr>
-              <a:t> Each roll week is compared with a control week four weeks earlier, same contract pair.</a:t>
+              <a:t> Roll week vs. a control week four weeks earlier. Listed-spread volume peaks in the roll week (80 to 87%).</a:t>
             </a:r>
           </a:p>
           <a:p>
@@ -6213,7 +6199,7 @@
                 </a:solidFill>
                 <a:latin typeface="Calibri"/>
               </a:rPr>
-              <a:t>Sign, Wilcoxon, bootstrap</a:t>
+              <a:t>Sign, Wilcoxon, bootstrap, runner</a:t>
             </a:r>
           </a:p>
         </p:txBody>
@@ -6399,7 +6385,7 @@
                 </a:solidFill>
                 <a:latin typeface="Cambria"/>
               </a:rPr>
-              <a:t>57 + 8</a:t>
+              <a:t>65 rolls</a:t>
             </a:r>
           </a:p>
         </p:txBody>
@@ -6434,7 +6420,7 @@
                 </a:solidFill>
                 <a:latin typeface="Calibri"/>
               </a:rPr>
-              <a:t>held-out rolls plus recent exploratory rolls</a:t>
+              <a:t>57 held out for the test, 8 recent ones exploratory</a:t>
             </a:r>
           </a:p>
         </p:txBody>
@@ -6469,7 +6455,7 @@
                 </a:solidFill>
                 <a:latin typeface="Cambria"/>
               </a:rPr>
-              <a:t>90+</a:t>
+              <a:t>190+</a:t>
             </a:r>
           </a:p>
         </p:txBody>
@@ -6565,14 +6551,14 @@
                 </a:solidFill>
                 <a:latin typeface="Cambria"/>
               </a:rPr>
-              <a:t>What the data show before any test</a:t>
+              <a:t>No evidence of a roll effect</a:t>
             </a:r>
           </a:p>
         </p:txBody>
       </p:sp>
       <p:graphicFrame>
         <p:nvGraphicFramePr>
-          <p:cNvPr id="3" name="Spread volume by week"/>
+          <p:cNvPr id="3" name="Mean absolute change"/>
           <p:cNvGraphicFramePr>
             <a:graphicFrameLocks noGrp="1"/>
           </p:cNvGraphicFramePr>
@@ -6580,7 +6566,7 @@
         </p:nvGraphicFramePr>
         <p:xfrm>
           <a:off x="457200" y="1234440"/>
-          <a:ext cx="4572000" cy="3246120"/>
+          <a:ext cx="4023360" cy="3200400"/>
         </p:xfrm>
         <a:graphic>
           <a:graphicData uri="http://schemas.openxmlformats.org/drawingml/2006/chart">
@@ -6590,14 +6576,14 @@
       </p:graphicFrame>
       <p:sp>
         <p:nvSpPr>
-          <p:cNvPr id="4" name="Findings"/>
+          <p:cNvPr id="4" name="TextBox 3"/>
           <p:cNvSpPr txBox="1"/>
           <p:nvPr/>
         </p:nvSpPr>
         <p:spPr>
           <a:xfrm>
-            <a:off x="5303520" y="1325880"/>
-            <a:ext cx="3383280" cy="3108960"/>
+            <a:off x="4846320" y="1325880"/>
+            <a:ext cx="3840480" cy="502920"/>
           </a:xfrm>
           <a:prstGeom prst="rect">
             <a:avLst/>
@@ -6610,81 +6596,15 @@
           </a:bodyPr>
           <a:lstStyle/>
           <a:p>
-            <a:pPr algn="l" marL="201168" indent="-201168">
-              <a:spcAft>
-                <a:spcPts val="1000"/>
-              </a:spcAft>
-              <a:buChar char="•"/>
-            </a:pPr>
-            <a:r>
-              <a:rPr sz="1400" b="1" i="0">
-                <a:solidFill>
-                  <a:srgbClr val="0F2A6B"/>
-                </a:solidFill>
-                <a:latin typeface="Calibri"/>
+            <a:pPr algn="l"/>
+            <a:r>
+              <a:rPr sz="2600" b="1" i="0">
+                <a:solidFill>
+                  <a:srgbClr val="3B5BA9"/>
+                </a:solidFill>
+                <a:latin typeface="Cambria"/>
               </a:rPr>
-              <a:t>Rolling is concentrated.</a:t>
-            </a:r>
-            <a:r>
-              <a:rPr sz="1400" b="0" i="0">
-                <a:solidFill>
-                  <a:srgbClr val="1B2336"/>
-                </a:solidFill>
-                <a:latin typeface="Calibri"/>
-              </a:rPr>
-              <a:t> 80 to 87% of listed-spread volume trades in the roll week, 0 to 1% in the control week.</a:t>
-            </a:r>
-          </a:p>
-          <a:p>
-            <a:pPr algn="l" marL="201168" indent="-201168">
-              <a:spcAft>
-                <a:spcPts val="1000"/>
-              </a:spcAft>
-              <a:buChar char="•"/>
-            </a:pPr>
-            <a:r>
-              <a:rPr sz="1400" b="1" i="0">
-                <a:solidFill>
-                  <a:srgbClr val="0F2A6B"/>
-                </a:solidFill>
-                <a:latin typeface="Calibri"/>
-              </a:rPr>
-              <a:t>Outright volume lags.</a:t>
-            </a:r>
-            <a:r>
-              <a:rPr sz="1400" b="0" i="0">
-                <a:solidFill>
-                  <a:srgbClr val="1B2336"/>
-                </a:solidFill>
-                <a:latin typeface="Calibri"/>
-              </a:rPr>
-              <a:t> The deferred contract passes half of outright volume 3 days before expiry in 63 of 65 rolls, about two days after spread trading peaks.</a:t>
-            </a:r>
-          </a:p>
-          <a:p>
-            <a:pPr algn="l" marL="201168" indent="-201168">
-              <a:spcAft>
-                <a:spcPts val="1000"/>
-              </a:spcAft>
-              <a:buChar char="•"/>
-            </a:pPr>
-            <a:r>
-              <a:rPr sz="1400" b="1" i="0">
-                <a:solidFill>
-                  <a:srgbClr val="0F2A6B"/>
-                </a:solidFill>
-                <a:latin typeface="Calibri"/>
-              </a:rPr>
-              <a:t>The control is thin.</a:t>
-            </a:r>
-            <a:r>
-              <a:rPr sz="1400" b="0" i="0">
-                <a:solidFill>
-                  <a:srgbClr val="1B2336"/>
-                </a:solidFill>
-                <a:latin typeface="Calibri"/>
-              </a:rPr>
-              <a:t> Control-week deferred quotes are about twice as wide, so control moves are noisier.</a:t>
+              <a:t>+0.52 ticks</a:t>
             </a:r>
           </a:p>
         </p:txBody>
@@ -6697,8 +6617,8 @@
         </p:nvSpPr>
         <p:spPr>
           <a:xfrm>
-            <a:off x="548640" y="4572000"/>
-            <a:ext cx="7589520" cy="274320"/>
+            <a:off x="4846320" y="1828800"/>
+            <a:ext cx="3840480" cy="365760"/>
           </a:xfrm>
           <a:prstGeom prst="rect">
             <a:avLst/>
@@ -6713,13 +6633,188 @@
           <a:p>
             <a:pPr algn="l"/>
             <a:r>
-              <a:rPr sz="1100" b="0" i="1">
-                <a:solidFill>
-                  <a:srgbClr val="7A869E"/>
+              <a:rPr sz="1300" b="0" i="0">
+                <a:solidFill>
+                  <a:srgbClr val="1B2336"/>
                 </a:solidFill>
                 <a:latin typeface="Calibri"/>
               </a:rPr>
-              <a:t>Exploratory: the 8 recent rolls, volume and quote quality only. No spread changes were examined.</a:t>
+              <a:t>mean of d = |roll| minus |control|, per roll</a:t>
+            </a:r>
+          </a:p>
+        </p:txBody>
+      </p:sp>
+      <p:sp>
+        <p:nvSpPr>
+          <p:cNvPr id="6" name="TextBox 5"/>
+          <p:cNvSpPr txBox="1"/>
+          <p:nvPr/>
+        </p:nvSpPr>
+        <p:spPr>
+          <a:xfrm>
+            <a:off x="4846320" y="2331720"/>
+            <a:ext cx="3840480" cy="502920"/>
+          </a:xfrm>
+          <a:prstGeom prst="rect">
+            <a:avLst/>
+          </a:prstGeom>
+          <a:noFill/>
+        </p:spPr>
+        <p:txBody>
+          <a:bodyPr wrap="square" lIns="0" rIns="0" tIns="0" bIns="0" anchor="t">
+            <a:spAutoFit/>
+          </a:bodyPr>
+          <a:lstStyle/>
+          <a:p>
+            <a:pPr algn="l"/>
+            <a:r>
+              <a:rPr sz="2600" b="1" i="0">
+                <a:solidFill>
+                  <a:srgbClr val="3B5BA9"/>
+                </a:solidFill>
+                <a:latin typeface="Cambria"/>
+              </a:rPr>
+              <a:t>−0.96 to +2.19</a:t>
+            </a:r>
+          </a:p>
+        </p:txBody>
+      </p:sp>
+      <p:sp>
+        <p:nvSpPr>
+          <p:cNvPr id="7" name="TextBox 6"/>
+          <p:cNvSpPr txBox="1"/>
+          <p:nvPr/>
+        </p:nvSpPr>
+        <p:spPr>
+          <a:xfrm>
+            <a:off x="4846320" y="2834639"/>
+            <a:ext cx="3840480" cy="365760"/>
+          </a:xfrm>
+          <a:prstGeom prst="rect">
+            <a:avLst/>
+          </a:prstGeom>
+          <a:noFill/>
+        </p:spPr>
+        <p:txBody>
+          <a:bodyPr wrap="square" lIns="0" rIns="0" tIns="0" bIns="0" anchor="t">
+            <a:spAutoFit/>
+          </a:bodyPr>
+          <a:lstStyle/>
+          <a:p>
+            <a:pPr algn="l"/>
+            <a:r>
+              <a:rPr sz="1300" b="0" i="0">
+                <a:solidFill>
+                  <a:srgbClr val="1B2336"/>
+                </a:solidFill>
+                <a:latin typeface="Calibri"/>
+              </a:rPr>
+              <a:t>95% bootstrap interval, includes zero</a:t>
+            </a:r>
+          </a:p>
+        </p:txBody>
+      </p:sp>
+      <p:sp>
+        <p:nvSpPr>
+          <p:cNvPr id="8" name="TextBox 7"/>
+          <p:cNvSpPr txBox="1"/>
+          <p:nvPr/>
+        </p:nvSpPr>
+        <p:spPr>
+          <a:xfrm>
+            <a:off x="4846320" y="3337560"/>
+            <a:ext cx="3840480" cy="502920"/>
+          </a:xfrm>
+          <a:prstGeom prst="rect">
+            <a:avLst/>
+          </a:prstGeom>
+          <a:noFill/>
+        </p:spPr>
+        <p:txBody>
+          <a:bodyPr wrap="square" lIns="0" rIns="0" tIns="0" bIns="0" anchor="t">
+            <a:spAutoFit/>
+          </a:bodyPr>
+          <a:lstStyle/>
+          <a:p>
+            <a:pPr algn="l"/>
+            <a:r>
+              <a:rPr sz="2600" b="1" i="0">
+                <a:solidFill>
+                  <a:srgbClr val="3B5BA9"/>
+                </a:solidFill>
+                <a:latin typeface="Cambria"/>
+              </a:rPr>
+              <a:t>p = 0.89 and 0.37</a:t>
+            </a:r>
+          </a:p>
+        </p:txBody>
+      </p:sp>
+      <p:sp>
+        <p:nvSpPr>
+          <p:cNvPr id="9" name="TextBox 8"/>
+          <p:cNvSpPr txBox="1"/>
+          <p:nvPr/>
+        </p:nvSpPr>
+        <p:spPr>
+          <a:xfrm>
+            <a:off x="4846320" y="3840480"/>
+            <a:ext cx="3840480" cy="365760"/>
+          </a:xfrm>
+          <a:prstGeom prst="rect">
+            <a:avLst/>
+          </a:prstGeom>
+          <a:noFill/>
+        </p:spPr>
+        <p:txBody>
+          <a:bodyPr wrap="square" lIns="0" rIns="0" tIns="0" bIns="0" anchor="t">
+            <a:spAutoFit/>
+          </a:bodyPr>
+          <a:lstStyle/>
+          <a:p>
+            <a:pPr algn="l"/>
+            <a:r>
+              <a:rPr sz="1300" b="0" i="0">
+                <a:solidFill>
+                  <a:srgbClr val="1B2336"/>
+                </a:solidFill>
+                <a:latin typeface="Calibri"/>
+              </a:rPr>
+              <a:t>sign test and Wilcoxon test</a:t>
+            </a:r>
+          </a:p>
+        </p:txBody>
+      </p:sp>
+      <p:sp>
+        <p:nvSpPr>
+          <p:cNvPr id="10" name="TextBox 9"/>
+          <p:cNvSpPr txBox="1"/>
+          <p:nvPr/>
+        </p:nvSpPr>
+        <p:spPr>
+          <a:xfrm>
+            <a:off x="548640" y="4526280"/>
+            <a:ext cx="8046720" cy="411480"/>
+          </a:xfrm>
+          <a:prstGeom prst="rect">
+            <a:avLst/>
+          </a:prstGeom>
+          <a:noFill/>
+        </p:spPr>
+        <p:txBody>
+          <a:bodyPr wrap="square" lIns="0" rIns="0" tIns="0" bIns="0" anchor="t">
+            <a:spAutoFit/>
+          </a:bodyPr>
+          <a:lstStyle/>
+          <a:p>
+            <a:pPr algn="l"/>
+            <a:r>
+              <a:rPr sz="1100" b="0" i="1">
+                <a:solidFill>
+                  <a:srgbClr val="7A869E"/>
+                </a:solidFill>
+                <a:latin typeface="Calibri"/>
+              </a:rPr>
+              <a:t>Planned sensitivity checks agree (narrow quotes, no Fed or ECB weeks, carry-adjusted). One added check, a 3-week control, is borderline. H3 not computed.</a:t>
             </a:r>
           </a:p>
         </p:txBody>
@@ -6780,14 +6875,14 @@
                 </a:solidFill>
                 <a:latin typeface="Cambria"/>
               </a:rPr>
-              <a:t>What we will and won't claim</a:t>
-            </a:r>
-          </a:p>
-        </p:txBody>
-      </p:sp>
-      <p:sp>
-        <p:nvSpPr>
-          <p:cNvPr id="3" name="Fixed card"/>
+              <a:t>What we can and can't conclude</a:t>
+            </a:r>
+          </a:p>
+        </p:txBody>
+      </p:sp>
+      <p:sp>
+        <p:nvSpPr>
+          <p:cNvPr id="3" name="Can say card"/>
           <p:cNvSpPr/>
           <p:nvPr/>
         </p:nvSpPr>
@@ -6863,7 +6958,7 @@
                 </a:solidFill>
                 <a:latin typeface="Cambria"/>
               </a:rPr>
-              <a:t>Fixed in advance</a:t>
+              <a:t>What we can say</a:t>
             </a:r>
           </a:p>
         </p:txBody>
@@ -6903,7 +6998,7 @@
                 </a:solidFill>
                 <a:latin typeface="Calibri"/>
               </a:rPr>
-              <a:t>Hypotheses, windows, snapshot time and quote-age limit</a:t>
+              <a:t>No detectable roll-week effect in 57 held-out rolls, and the planned sensitivity checks agree</a:t>
             </a:r>
           </a:p>
           <a:p>
@@ -6920,7 +7015,7 @@
                 </a:solidFill>
                 <a:latin typeface="Calibri"/>
               </a:rPr>
-              <a:t>Sign test, Wilcoxon test and two bootstrap intervals</a:t>
+              <a:t>Listed-spread volume does concentrate in the roll week</a:t>
             </a:r>
           </a:p>
           <a:p>
@@ -6937,31 +7032,14 @@
                 </a:solidFill>
                 <a:latin typeface="Calibri"/>
               </a:rPr>
-              <a:t>Observed USD and EUR rates for a carry comparison</a:t>
-            </a:r>
-          </a:p>
-          <a:p>
-            <a:pPr algn="l" marL="201168" indent="-201168">
-              <a:spcAft>
-                <a:spcPts val="800"/>
-              </a:spcAft>
-              <a:buChar char="•"/>
-            </a:pPr>
-            <a:r>
-              <a:rPr sz="1400" b="0" i="0">
-                <a:solidFill>
-                  <a:srgbClr val="1B2336"/>
-                </a:solidFill>
-                <a:latin typeface="Calibri"/>
-              </a:rPr>
-              <a:t>Plan signed off by all four before the test runs</a:t>
-            </a:r>
-          </a:p>
-        </p:txBody>
-      </p:sp>
-      <p:sp>
-        <p:nvSpPr>
-          <p:cNvPr id="6" name="Limits card"/>
+              <a:t>The plan was written before the test, and every later change is logged</a:t>
+            </a:r>
+          </a:p>
+        </p:txBody>
+      </p:sp>
+      <p:sp>
+        <p:nvSpPr>
+          <p:cNvPr id="6" name="Cannot say card"/>
           <p:cNvSpPr/>
           <p:nvPr/>
         </p:nvSpPr>
@@ -7037,7 +7115,7 @@
                 </a:solidFill>
                 <a:latin typeface="Cambria"/>
               </a:rPr>
-              <a:t>Limits and next steps</a:t>
+              <a:t>What we can't say</a:t>
             </a:r>
           </a:p>
         </p:txBody>
@@ -7077,7 +7155,7 @@
                 </a:solidFill>
                 <a:latin typeface="Calibri"/>
               </a:rPr>
-              <a:t>A null result is not proof of no effect: noisy control quotes bias the test toward none</a:t>
+              <a:t>That there is no effect: noisy control quotes bias the test toward none, and a move 1.5 times the control's is caught only 29 to 43% of the time</a:t>
             </a:r>
           </a:p>
           <a:p>
@@ -7094,7 +7172,7 @@
                 </a:solidFill>
                 <a:latin typeface="Calibri"/>
               </a:rPr>
-              <a:t>Spread moves also reflect rates; we cannot show who pays</a:t>
+              <a:t>Who pays, or that rolling caused any move</a:t>
             </a:r>
           </a:p>
           <a:p>
@@ -7111,7 +7189,7 @@
                 </a:solidFill>
                 <a:latin typeface="Calibri"/>
               </a:rPr>
-              <a:t>Next: per-roll table, main test on 57 rolls, robustness checks, report</a:t>
+              <a:t>That the plan was fully frozen: the test ran before the last sign-off</a:t>
             </a:r>
           </a:p>
         </p:txBody>

</xml_diff>

<commit_message>
Mark every pipeline step merged on the slides
Co-Authored-By: Claude Sonnet 5.5 <noreply@anthropic.com>
</commit_message>
<xml_diff>
--- a/docs/project_slides.pptx
+++ b/docs/project_slides.pptx
@@ -836,7 +836,7 @@
           <a:lstStyle/>
           <a:p>
             <a:r>
-              <a:t>Everything is a Python package with tests, built through pull requests that every member reviews. The data step downloads named contracts from Databento and caches them locally. The roll calendar uses the formula 'two business days before the third Wednesday' and we checked it against Databento's own definitions: 64 of 65 match. The one miss, 6EM3 in June 2023, expired a business day early because of Juneteenth, a CME holiday; the fix is in review along with the statistics and the main-test runner. Statuses are as of October 26.</a:t>
+              <a:t>Everything is a Python package with tests, built through pull requests that every member reviews. The data step downloads named contracts from Databento and caches them locally. The roll calendar uses the formula 'two business days before the third Wednesday' and we checked it against Databento's own definitions: 64 of 65 match. The one miss, 6EM3 in June 2023, expired a business day early because of Juneteenth, a CME holiday; the holiday fix, the statistics and the main-test runner were merged on October 26.</a:t>
             </a:r>
           </a:p>
         </p:txBody>
@@ -906,7 +906,7 @@
           <a:lstStyle/>
           <a:p>
             <a:r>
-              <a:t>This is the main test on the 57 held-out rolls from September 2010 to September 2024. Roll weeks move a little more than control weeks, 3.2 ticks against 2.7 on average, but the average difference of half a tick is well inside the noise: the 95 percent interval runs from minus 1 to plus 2.2 ticks, and both the sign test and the Wilcoxon test are far from significant. The spread rose in 24 of the 50 roll weeks with a nonzero move, so there is no consistent direction either. The planned sensitivity checks, which drop wide quotes, drop weeks with Fed or ECB decisions, and adjust for carry, all agree. One added check, a control week three weeks out instead of four, gives a block-bootstrap interval that just excludes zero; it was not in the plan and comes from three large roll weeks. Because H1 and H2 do not hold we do not compute H3, the dollar cost. Numbers are from the main-test pull request, which is still in review.</a:t>
+              <a:t>This is the main test on the 57 held-out rolls from September 2010 to September 2024. Roll weeks move a little more than control weeks, 3.2 ticks against 2.7 on average, but the average difference of half a tick is well inside the noise: the 95 percent interval runs from minus 1 to plus 2.2 ticks, and both the sign test and the Wilcoxon test are far from significant. The spread rose in 24 of the 50 roll weeks with a nonzero move, so there is no consistent direction either. The planned sensitivity checks, which drop wide quotes, drop weeks with Fed or ECB decisions, and adjust for carry, all agree. One added check, a control week three weeks out instead of four, gives a block-bootstrap interval that just excludes zero; it was not in the plan and comes from three large roll weeks. Because H1 and H2 do not hold we do not compute H3, the dollar cost. Numbers are from the main-test pull request, merged on October 26.</a:t>
             </a:r>
           </a:p>
         </p:txBody>
@@ -5519,7 +5519,7 @@
             </a:avLst>
           </a:prstGeom>
           <a:solidFill>
-            <a:srgbClr val="E3A71B"/>
+            <a:srgbClr val="2E8B6E"/>
           </a:solidFill>
           <a:ln>
             <a:noFill/>
@@ -5574,11 +5574,11 @@
             <a:r>
               <a:rPr sz="1100" b="1" i="0">
                 <a:solidFill>
-                  <a:srgbClr val="1B2336"/>
+                  <a:srgbClr val="FFFFFF"/>
                 </a:solidFill>
                 <a:latin typeface="Calibri"/>
               </a:rPr>
-              <a:t>in review</a:t>
+              <a:t>merged</a:t>
             </a:r>
           </a:p>
         </p:txBody>
@@ -6221,7 +6221,7 @@
             </a:avLst>
           </a:prstGeom>
           <a:solidFill>
-            <a:srgbClr val="E3A71B"/>
+            <a:srgbClr val="2E8B6E"/>
           </a:solidFill>
           <a:ln>
             <a:noFill/>
@@ -6276,11 +6276,11 @@
             <a:r>
               <a:rPr sz="1100" b="1" i="0">
                 <a:solidFill>
-                  <a:srgbClr val="1B2336"/>
+                  <a:srgbClr val="FFFFFF"/>
                 </a:solidFill>
                 <a:latin typeface="Calibri"/>
               </a:rPr>
-              <a:t>in review</a:t>
+              <a:t>merged</a:t>
             </a:r>
           </a:p>
         </p:txBody>

</xml_diff>

<commit_message>
Name H1 and H2 where later slides use them
Co-Authored-By: Claude Sonnet 5.5 <noreply@anthropic.com>
</commit_message>
<xml_diff>
--- a/docs/project_slides.pptx
+++ b/docs/project_slides.pptx
@@ -8287,7 +8287,7 @@
                 </a:solidFill>
                 <a:latin typeface="Calibri"/>
               </a:rPr>
-              <a:t>H1: mean of d = |roll| minus |control|, per roll</a:t>
+              <a:t>H1 (magnitude): mean of d = |roll| minus |control|, per roll</a:t>
             </a:r>
           </a:p>
         </p:txBody>
@@ -8497,7 +8497,7 @@
                 </a:solidFill>
                 <a:latin typeface="Calibri"/>
               </a:rPr>
-              <a:t>roll weeks where the spread rose (H2), p = 0.89</a:t>
+              <a:t>roll weeks where the spread rose (H2, direction), p = 0.89</a:t>
             </a:r>
           </a:p>
         </p:txBody>
@@ -8532,7 +8532,7 @@
                 </a:solidFill>
                 <a:latin typeface="Calibri"/>
               </a:rPr>
-              <a:t>57 held-out rolls, September 2010 to September 2024. H3 (the dollar cost) is not computed because H1 and H2 do not hold.</a:t>
+              <a:t>57 held-out rolls, September 2010 to September 2024. H3 (the dollar cost) is not computed because H1 (magnitude) and H2 (direction) do not hold.</a:t>
             </a:r>
           </a:p>
         </p:txBody>
@@ -9865,7 +9865,7 @@
                 </a:solidFill>
                 <a:latin typeface="Calibri"/>
               </a:rPr>
-              <a:t>H1 estimate in ticks, with 95% interval</a:t>
+              <a:t>H1 (magnitude) estimate in ticks, with 95% interval</a:t>
             </a:r>
           </a:p>
         </p:txBody>

</xml_diff>

<commit_message>
Give the slide 6 footnote room for two lines
Co-Authored-By: Claude Sonnet 5.5 <noreply@anthropic.com>
</commit_message>
<xml_diff>
--- a/docs/project_slides.pptx
+++ b/docs/project_slides.pptx
@@ -8287,7 +8287,7 @@
                 </a:solidFill>
                 <a:latin typeface="Calibri"/>
               </a:rPr>
-              <a:t>H1 (magnitude): mean of d = |roll| minus |control|, per roll</a:t>
+              <a:t>H1 (magnitude): mean of |roll| minus |control|</a:t>
             </a:r>
           </a:p>
         </p:txBody>
@@ -8497,7 +8497,7 @@
                 </a:solidFill>
                 <a:latin typeface="Calibri"/>
               </a:rPr>
-              <a:t>roll weeks where the spread rose (H2, direction), p = 0.89</a:t>
+              <a:t>roll weeks with a rise (H2, direction), p = 0.89</a:t>
             </a:r>
           </a:p>
         </p:txBody>
@@ -8510,8 +8510,8 @@
         </p:nvSpPr>
         <p:spPr>
           <a:xfrm>
-            <a:off x="548640" y="4572000"/>
-            <a:ext cx="8046720" cy="274320"/>
+            <a:off x="548640" y="4526280"/>
+            <a:ext cx="8046720" cy="411480"/>
           </a:xfrm>
           <a:prstGeom prst="rect">
             <a:avLst/>

</xml_diff>